<commit_message>
Bloco 7: relatório, apresentação e ZIP regenerados
- relatorio.md -> DOCX e PDF (43 páginas, índice atualizado)
- Apresentação: contagens novas, fluxo de pagamento revisto, novos serviços
- ZIP PGP-2627-G12-E1.ZIP com a mesma estrutura de pastas
- Ferramentas de geração guardadas em etapa1/ferramentas/
</commit_message>
<xml_diff>
--- a/etapa1/relatorio/PGP-2627-G12-E1-apresentacao.pptx
+++ b/etapa1/relatorio/PGP-2627-G12-E1-apresentacao.pptx
@@ -119,42 +119,42 @@
   <p:extLst>
     <p:ext uri="{521415D9-36F7-43E2-AB2F-B90AF26B5E84}">
       <p14:sectionLst xmlns:p14="http://schemas.microsoft.com/office/powerpoint/2010/main">
-        <p14:section name="Abertura" id="{127363a4-1fba-f264-c725-fefaf3d95d74}">
+        <p14:section name="Abertura" id="{6f6ed963-baa9-da0a-5b66-06c615b5dcaf}">
           <p14:sldIdLst>
             <p14:sldId id="256"/>
           </p14:sldIdLst>
         </p14:section>
-        <p14:section name="Casos de uso" id="{18d383b9-453b-c0e6-a8d3-dfb41f033e54}">
+        <p14:section name="Casos de uso" id="{4b44482e-1545-cdcc-6396-450ad47d727a}">
           <p14:sldIdLst>
             <p14:sldId id="257"/>
             <p14:sldId id="258"/>
           </p14:sldIdLst>
         </p14:section>
-        <p14:section name="Modelo de dados" id="{a95a25f2-482d-1fc7-dc09-71f3852a3bc9}">
+        <p14:section name="Modelo de dados" id="{0512a545-cf29-856b-27ca-9ecf8d6ab5b5}">
           <p14:sldIdLst>
             <p14:sldId id="259"/>
             <p14:sldId id="260"/>
           </p14:sldIdLst>
         </p14:section>
-        <p14:section name="Restrições e serviços" id="{3bfe0ad6-e719-e29b-7868-e7580629837b}">
+        <p14:section name="Restrições e serviços" id="{5d09e1ba-6e42-ecd1-3153-3f61f1ce953f}">
           <p14:sldIdLst>
             <p14:sldId id="261"/>
             <p14:sldId id="262"/>
           </p14:sldIdLst>
         </p14:section>
-        <p14:section name="Fluxos" id="{ac747404-6e4b-51cd-15c2-15b63a99ef1d}">
+        <p14:section name="Fluxos" id="{ddd421d8-0247-c016-1bf0-e2dbf65bcb72}">
           <p14:sldIdLst>
             <p14:sldId id="263"/>
             <p14:sldId id="264"/>
           </p14:sldIdLst>
         </p14:section>
-        <p14:section name="Esboços" id="{98c8df30-4037-462b-7503-dae834efe33c}">
+        <p14:section name="Esboços" id="{716d1cb9-bdf2-bc9a-0f40-a3f27ff95f44}">
           <p14:sldIdLst>
             <p14:sldId id="265"/>
             <p14:sldId id="266"/>
           </p14:sldIdLst>
         </p14:section>
-        <p14:section name="Fecho" id="{9151e69a-eba4-67ff-4cd1-06433f0fdaf0}">
+        <p14:section name="Fecho" id="{55b2cd84-5e82-d8a2-0a0c-fd00f6d27c43}">
           <p14:sldIdLst>
             <p14:sldId id="267"/>
             <p14:sldId id="268"/>
@@ -1092,7 +1092,7 @@
           <a:p>
             <a:r>
               <a:rPr lang="en-US" dirty="0"/>
-              <a:t>Reis: o utilizador tem 16 casos de uso, o gestor 6, e o 'Iniciar sessão' é comum. User stories sobre os mesmos dados foram agrupadas (ex.: Gerir coleção = US10 + US11). Única relação: Gerir artista favorito «extend» Visualizar página de artista.</a:t>
+              <a:t>Reis: o utilizador tem 16 casos de uso, o gestor 7; 'Iniciar sessão' e 'Visualizar página de álbum' são comuns. User stories sobre os mesmos dados foram agrupadas (ex.: Gerir coleção = US10 + US11). Duas relações «extend»: Gerir artista favorito estende Visualizar página de artista, e Gerir stock estende Visualizar página de álbum (o gestor altera o stock a partir dessa página, US25 a).</a:t>
             </a:r>
             <a:endParaRPr lang="en-US" dirty="0"/>
           </a:p>
@@ -1356,7 +1356,7 @@
           <a:p>
             <a:r>
               <a:rPr lang="en-US" dirty="0"/>
-              <a:t>Ze: as 30 restrições do enunciado estão nas notas dos diagramas. Encontrámos mais 17 lendo os critérios de aceitação das user stories — nenhuma foi inventada, cada uma tem a frase de origem. Exemplos na tabela.</a:t>
+              <a:t>Ze: as 30 restrições do enunciado estão nas notas dos diagramas. Encontrámos mais 21 lendo os critérios de aceitação das user stories — nenhuma foi inventada, cada uma tem a frase de origem. Exemplos na tabela.</a:t>
             </a:r>
             <a:endParaRPr lang="en-US" dirty="0"/>
           </a:p>
@@ -1532,7 +1532,7 @@
           <a:p>
             <a:r>
               <a:rPr lang="en-US" dirty="0"/>
-              <a:t>Edson: a compra tem um diagrama de alto nível (pesquisa → carrinho → pagar) e o pagamento está decomposto numa subatividade, como pede o enunciado. Raias: utilizador, aplicação, serviço de pagamentos.</a:t>
+              <a:t>Edson: a compra tem um diagrama de alto nível (pesquisa → carrinho → pagar) e o pagamento está decomposto numa subatividade, como pede o enunciado. Raias: utilizador, aplicação, serviço de pagamentos. Notação UML: decisões em losango com guardas [ ], barras de fork/join. A reserva das unidades resolve o caso de dois utilizadores a comprarem a última unidade ao mesmo tempo.</a:t>
             </a:r>
             <a:endParaRPr lang="en-US" dirty="0"/>
           </a:p>
@@ -4738,7 +4738,7 @@
                 <a:ea typeface="Cambria" pitchFamily="34" charset="-122"/>
                 <a:cs typeface="Cambria" pitchFamily="34" charset="-120"/>
               </a:rPr>
-              <a:t>3</a:t>
+              <a:t>5</a:t>
             </a:r>
             <a:endParaRPr lang="en-US" sz="6000" dirty="0"/>
           </a:p>
@@ -5021,8 +5021,8 @@
         </p:blipFill>
         <p:spPr>
           <a:xfrm>
-            <a:off x="4754880" y="1504111"/>
-            <a:ext cx="4023360" cy="2386739"/>
+            <a:off x="4899074" y="1463040"/>
+            <a:ext cx="3734972" cy="2468880"/>
           </a:xfrm>
           <a:prstGeom prst="rect">
             <a:avLst/>
@@ -5322,8 +5322,8 @@
         </p:blipFill>
         <p:spPr>
           <a:xfrm>
-            <a:off x="809733" y="1371600"/>
-            <a:ext cx="10542054" cy="4297680"/>
+            <a:off x="2931965" y="1371600"/>
+            <a:ext cx="6297590" cy="4297680"/>
           </a:xfrm>
           <a:prstGeom prst="rect">
             <a:avLst/>
@@ -5605,8 +5605,8 @@
         </p:blipFill>
         <p:spPr>
           <a:xfrm>
-            <a:off x="548640" y="1710464"/>
-            <a:ext cx="4206240" cy="4260032"/>
+            <a:off x="638057" y="1371600"/>
+            <a:ext cx="4027406" cy="4937760"/>
           </a:xfrm>
           <a:prstGeom prst="rect">
             <a:avLst/>
@@ -6418,7 +6418,7 @@
                 <a:ea typeface="Cambria" pitchFamily="34" charset="-122"/>
                 <a:cs typeface="Cambria" pitchFamily="34" charset="-120"/>
               </a:rPr>
-              <a:t>+17</a:t>
+              <a:t>+21</a:t>
             </a:r>
             <a:endParaRPr lang="en-US" sz="6000" dirty="0"/>
           </a:p>
@@ -7586,7 +7586,7 @@
                   <a:schemeClr val="tx2"/>
                 </a:solidFill>
               </a:rPr>
-              <a:t>Todas as 47 restrições estão associadas a uma classe do modelo (Anexo A do relatório).</a:t>
+              <a:t>Todas as 51 restrições estão associadas a uma classe do modelo (Anexo A do relatório).</a:t>
             </a:r>
             <a:endParaRPr lang="en-US" sz="1400" dirty="0"/>
           </a:p>
@@ -8220,6 +8220,53 @@
       </p:sp>
       <p:sp>
         <p:nvSpPr>
+          <p:cNvPr id="18" name="outros-servicos"/>
+          <p:cNvSpPr txBox="1"/>
+          <p:nvPr/>
+        </p:nvSpPr>
+        <p:spPr>
+          <a:xfrm>
+            <a:off x="548640" y="5303520"/>
+            <a:ext cx="11064240" cy="548640"/>
+          </a:xfrm>
+          <a:prstGeom prst="rect">
+            <a:avLst/>
+          </a:prstGeom>
+          <a:noFill/>
+          <a:ln/>
+        </p:spPr>
+        <p:txBody>
+          <a:bodyPr wrap="square" lIns="0" tIns="0" rIns="0" bIns="0" rtlCol="0" anchor="ctr"/>
+          <a:lstStyle/>
+          <a:p>
+            <a:pPr indent="0" marL="0">
+              <a:buNone/>
+            </a:pPr>
+            <a:r>
+              <a:rPr lang="en-US" sz="1500" b="1" dirty="0">
+                <a:solidFill>
+                  <a:schemeClr val="tx1"/>
+                </a:solidFill>
+              </a:rPr>
+              <a:t>Também pesquisados: </a:t>
+            </a:r>
+            <a:pPr indent="0" marL="0">
+              <a:buNone/>
+            </a:pPr>
+            <a:r>
+              <a:rPr lang="en-US" sz="1500" dirty="0">
+                <a:solidFill>
+                  <a:schemeClr val="tx1"/>
+                </a:solidFill>
+              </a:rPr>
+              <a:t>imagens de capa no Cloudinary, com sugestão do Cover Art Archive pelo MBID; faixas e canções importadas da API do MusicBrainz (dados CC0).</a:t>
+            </a:r>
+            <a:endParaRPr lang="en-US" sz="1500" dirty="0"/>
+          </a:p>
+        </p:txBody>
+      </p:sp>
+      <p:sp>
+        <p:nvSpPr>
           <p:cNvPr id="25" name="Slide Number Placeholder 0"/>
           <p:cNvSpPr>
             <a:spLocks noGrp="1"/>
@@ -8428,8 +8475,8 @@
         </p:blipFill>
         <p:spPr>
           <a:xfrm>
-            <a:off x="818599" y="1280160"/>
-            <a:ext cx="2751921" cy="5074920"/>
+            <a:off x="573534" y="1280160"/>
+            <a:ext cx="3242052" cy="5074920"/>
           </a:xfrm>
           <a:prstGeom prst="rect">
             <a:avLst/>
@@ -8534,7 +8581,7 @@
                   <a:schemeClr val="tx1"/>
                 </a:solidFill>
               </a:rPr>
-              <a:t>O utilizador escolhe Stripe ou PayPal e paga na página do serviço</a:t>
+              <a:t>Reserva as unidades; se uma versão esgotou entretanto, sai do carrinho</a:t>
             </a:r>
             <a:endParaRPr lang="en-US" sz="1500" dirty="0"/>
           </a:p>
@@ -8631,7 +8678,7 @@
                   <a:schemeClr val="tx1"/>
                 </a:solidFill>
               </a:rPr>
-              <a:t>A aplicação espera pelo resultado enviado pelo serviço (US28 c)</a:t>
+              <a:t>O utilizador escolhe Stripe ou PayPal e paga na página do serviço</a:t>
             </a:r>
             <a:endParaRPr lang="en-US" sz="1500" dirty="0"/>
           </a:p>
@@ -8728,7 +8775,7 @@
                   <a:schemeClr val="tx1"/>
                 </a:solidFill>
               </a:rPr>
-              <a:t>Sucesso: fatura, coleção atualizada e stock descontado</a:t>
+              <a:t>Espera pelo resultado (US28 c); sem resposta no tempo limite, liberta a reserva</a:t>
             </a:r>
             <a:endParaRPr lang="en-US" sz="1500" dirty="0"/>
           </a:p>
@@ -8825,7 +8872,7 @@
                   <a:schemeClr val="tx1"/>
                 </a:solidFill>
               </a:rPr>
-              <a:t>Última unidade vendida: regista a data da última venda (RI-17)</a:t>
+              <a:t>Sucesso: emite a fatura; coleção e stock atualizados em paralelo (fork/join)</a:t>
             </a:r>
             <a:endParaRPr lang="en-US" sz="1500" dirty="0"/>
           </a:p>
@@ -9138,8 +9185,8 @@
         </p:blipFill>
         <p:spPr>
           <a:xfrm>
-            <a:off x="761002" y="1280160"/>
-            <a:ext cx="3232875" cy="5074920"/>
+            <a:off x="589844" y="1280160"/>
+            <a:ext cx="3575193" cy="5074920"/>
           </a:xfrm>
           <a:prstGeom prst="rect">
             <a:avLst/>

</xml_diff>